<commit_message>
chore: checkpoint current workspace updates
</commit_message>
<xml_diff>
--- a/docs/benchmarks/results/exports/c9ebf838-0a1c-45ef-be39-2fd5d6163367/deck.pptx
+++ b/docs/benchmarks/results/exports/c9ebf838-0a1c-45ef-be39-2fd5d6163367/deck.pptx
@@ -303,7 +303,7 @@
             <a:pPr lvl="0"/>
             <a:r>
               <a:rPr lang="zh-CN" altLang="en-US"/>
-              <a:t>单击此处编辑母版文本样式</a:t>
+              <a:t>编辑母版文本样式</a:t>
             </a:r>
           </a:p>
           <a:p>
@@ -338,7 +338,7 @@
       </p:sp>
       <p:sp>
         <p:nvSpPr>
-          <p:cNvPr id="6" name="页脚占位符 5"/>
+          <p:cNvPr id="6" name="占位符 5"/>
           <p:cNvSpPr>
             <a:spLocks noGrp="1"/>
           </p:cNvSpPr>
@@ -1108,14 +1108,14 @@
           <a:p>
             <a:r>
               <a:rPr kumimoji="1" lang="zh-CN" altLang="en-US"/>
-              <a:t>单击此处编辑母版标题样式</a:t>
+              <a:t>编辑母版标题样式</a:t>
             </a:r>
           </a:p>
         </p:txBody>
       </p:sp>
       <p:sp>
         <p:nvSpPr>
-          <p:cNvPr id="3" name="副标题 2">
+          <p:cNvPr id="3" name=" 2">
             <a:extLst>
               <a:ext uri="{FF2B5EF4-FFF2-40B4-BE49-F238E27FC236}">
                 <a16:creationId xmlns:a16="http://schemas.microsoft.com/office/drawing/2014/main" id="{44E9A8A2-FD04-2244-8421-6736AD57235C}"/>
@@ -1126,7 +1126,7 @@
             <a:spLocks noGrp="1"/>
           </p:cNvSpPr>
           <p:nvPr>
-            <p:ph type="subTitle" idx="1"/>
+            <p:ph type="" idx="1"/>
           </p:nvPr>
         </p:nvSpPr>
         <p:spPr>
@@ -1178,7 +1178,7 @@
           <a:p>
             <a:r>
               <a:rPr kumimoji="1" lang="zh-CN" altLang="en-US"/>
-              <a:t>单击此处编辑母版副标题样式</a:t>
+              <a:t>编辑母版样式</a:t>
             </a:r>
           </a:p>
         </p:txBody>
@@ -1213,7 +1213,7 @@
       </p:sp>
       <p:sp>
         <p:nvSpPr>
-          <p:cNvPr id="5" name="页脚占位符 4">
+          <p:cNvPr id="5" name="占位符 4">
             <a:extLst>
               <a:ext uri="{FF2B5EF4-FFF2-40B4-BE49-F238E27FC236}">
                 <a16:creationId xmlns:a16="http://schemas.microsoft.com/office/drawing/2014/main" id="{73446B59-E837-B94F-B183-33E9C9489CA8}"/>
@@ -1317,7 +1317,7 @@
           <a:p>
             <a:r>
               <a:rPr kumimoji="1" lang="zh-CN" altLang="en-US"/>
-              <a:t>单击此处编辑母版标题样式</a:t>
+              <a:t>编辑母版标题样式</a:t>
             </a:r>
           </a:p>
         </p:txBody>
@@ -1346,7 +1346,7 @@
             <a:pPr lvl="0"/>
             <a:r>
               <a:rPr kumimoji="1" lang="zh-CN" altLang="en-US"/>
-              <a:t>单击此处编辑母版文本样式</a:t>
+              <a:t>编辑母版文本样式</a:t>
             </a:r>
           </a:p>
           <a:p>
@@ -1409,7 +1409,7 @@
       </p:sp>
       <p:sp>
         <p:nvSpPr>
-          <p:cNvPr id="5" name="页脚占位符 4">
+          <p:cNvPr id="5" name="占位符 4">
             <a:extLst>
               <a:ext uri="{FF2B5EF4-FFF2-40B4-BE49-F238E27FC236}">
                 <a16:creationId xmlns:a16="http://schemas.microsoft.com/office/drawing/2014/main" id="{12235E66-F75A-2943-A9E5-3FEC636D486F}"/>
@@ -1518,7 +1518,7 @@
           <a:p>
             <a:r>
               <a:rPr kumimoji="1" lang="zh-CN" altLang="en-US"/>
-              <a:t>单击此处编辑母版标题样式</a:t>
+              <a:t>编辑母版标题样式</a:t>
             </a:r>
           </a:p>
         </p:txBody>
@@ -1552,7 +1552,7 @@
             <a:pPr lvl="0"/>
             <a:r>
               <a:rPr kumimoji="1" lang="zh-CN" altLang="en-US"/>
-              <a:t>单击此处编辑母版文本样式</a:t>
+              <a:t>编辑母版文本样式</a:t>
             </a:r>
           </a:p>
           <a:p>
@@ -1615,7 +1615,7 @@
       </p:sp>
       <p:sp>
         <p:nvSpPr>
-          <p:cNvPr id="5" name="页脚占位符 4">
+          <p:cNvPr id="5" name="占位符 4">
             <a:extLst>
               <a:ext uri="{FF2B5EF4-FFF2-40B4-BE49-F238E27FC236}">
                 <a16:creationId xmlns:a16="http://schemas.microsoft.com/office/drawing/2014/main" id="{6CB046B9-28CD-7E40-B865-CBD300AB80AF}"/>
@@ -1719,7 +1719,7 @@
           <a:p>
             <a:r>
               <a:rPr kumimoji="1" lang="zh-CN" altLang="en-US"/>
-              <a:t>单击此处编辑母版标题样式</a:t>
+              <a:t>编辑母版标题样式</a:t>
             </a:r>
           </a:p>
         </p:txBody>
@@ -1748,7 +1748,7 @@
             <a:pPr lvl="0"/>
             <a:r>
               <a:rPr kumimoji="1" lang="zh-CN" altLang="en-US"/>
-              <a:t>单击此处编辑母版文本样式</a:t>
+              <a:t>编辑母版文本样式</a:t>
             </a:r>
           </a:p>
           <a:p>
@@ -1811,7 +1811,7 @@
       </p:sp>
       <p:sp>
         <p:nvSpPr>
-          <p:cNvPr id="5" name="页脚占位符 4">
+          <p:cNvPr id="5" name="占位符 4">
             <a:extLst>
               <a:ext uri="{FF2B5EF4-FFF2-40B4-BE49-F238E27FC236}">
                 <a16:creationId xmlns:a16="http://schemas.microsoft.com/office/drawing/2014/main" id="{4BA7FE07-3A22-C549-8BA1-9144E9B9AA29}"/>
@@ -1924,7 +1924,7 @@
           <a:p>
             <a:r>
               <a:rPr kumimoji="1" lang="zh-CN" altLang="en-US"/>
-              <a:t>单击此处编辑母版标题样式</a:t>
+              <a:t>编辑母版标题样式</a:t>
             </a:r>
           </a:p>
         </p:txBody>
@@ -2049,7 +2049,7 @@
             <a:pPr lvl="0"/>
             <a:r>
               <a:rPr kumimoji="1" lang="zh-CN" altLang="en-US"/>
-              <a:t>单击此处编辑母版文本样式</a:t>
+              <a:t>编辑母版文本样式</a:t>
             </a:r>
           </a:p>
         </p:txBody>
@@ -2084,7 +2084,7 @@
       </p:sp>
       <p:sp>
         <p:nvSpPr>
-          <p:cNvPr id="5" name="页脚占位符 4">
+          <p:cNvPr id="5" name="占位符 4">
             <a:extLst>
               <a:ext uri="{FF2B5EF4-FFF2-40B4-BE49-F238E27FC236}">
                 <a16:creationId xmlns:a16="http://schemas.microsoft.com/office/drawing/2014/main" id="{312B4834-C1BB-1B44-BF19-1B50911F2C42}"/>
@@ -2188,7 +2188,7 @@
           <a:p>
             <a:r>
               <a:rPr kumimoji="1" lang="zh-CN" altLang="en-US"/>
-              <a:t>单击此处编辑母版标题样式</a:t>
+              <a:t>编辑母版标题样式</a:t>
             </a:r>
           </a:p>
         </p:txBody>
@@ -2222,7 +2222,7 @@
             <a:pPr lvl="0"/>
             <a:r>
               <a:rPr kumimoji="1" lang="zh-CN" altLang="en-US"/>
-              <a:t>单击此处编辑母版文本样式</a:t>
+              <a:t>编辑母版文本样式</a:t>
             </a:r>
           </a:p>
           <a:p>
@@ -2284,7 +2284,7 @@
             <a:pPr lvl="0"/>
             <a:r>
               <a:rPr kumimoji="1" lang="zh-CN" altLang="en-US"/>
-              <a:t>单击此处编辑母版文本样式</a:t>
+              <a:t>编辑母版文本样式</a:t>
             </a:r>
           </a:p>
           <a:p>
@@ -2347,7 +2347,7 @@
       </p:sp>
       <p:sp>
         <p:nvSpPr>
-          <p:cNvPr id="6" name="页脚占位符 5">
+          <p:cNvPr id="6" name="占位符 5">
             <a:extLst>
               <a:ext uri="{FF2B5EF4-FFF2-40B4-BE49-F238E27FC236}">
                 <a16:creationId xmlns:a16="http://schemas.microsoft.com/office/drawing/2014/main" id="{19E43B05-B98B-F74C-9B0D-D350AFB75BD5}"/>
@@ -2456,7 +2456,7 @@
           <a:p>
             <a:r>
               <a:rPr kumimoji="1" lang="zh-CN" altLang="en-US"/>
-              <a:t>单击此处编辑母版标题样式</a:t>
+              <a:t>编辑母版标题样式</a:t>
             </a:r>
           </a:p>
         </p:txBody>
@@ -2527,7 +2527,7 @@
             <a:pPr lvl="0"/>
             <a:r>
               <a:rPr kumimoji="1" lang="zh-CN" altLang="en-US"/>
-              <a:t>单击此处编辑母版文本样式</a:t>
+              <a:t>编辑母版文本样式</a:t>
             </a:r>
           </a:p>
         </p:txBody>
@@ -2561,7 +2561,7 @@
             <a:pPr lvl="0"/>
             <a:r>
               <a:rPr kumimoji="1" lang="zh-CN" altLang="en-US"/>
-              <a:t>单击此处编辑母版文本样式</a:t>
+              <a:t>编辑母版文本样式</a:t>
             </a:r>
           </a:p>
           <a:p>
@@ -2660,7 +2660,7 @@
             <a:pPr lvl="0"/>
             <a:r>
               <a:rPr kumimoji="1" lang="zh-CN" altLang="en-US"/>
-              <a:t>单击此处编辑母版文本样式</a:t>
+              <a:t>编辑母版文本样式</a:t>
             </a:r>
           </a:p>
         </p:txBody>
@@ -2694,7 +2694,7 @@
             <a:pPr lvl="0"/>
             <a:r>
               <a:rPr kumimoji="1" lang="zh-CN" altLang="en-US"/>
-              <a:t>单击此处编辑母版文本样式</a:t>
+              <a:t>编辑母版文本样式</a:t>
             </a:r>
           </a:p>
           <a:p>
@@ -2757,7 +2757,7 @@
       </p:sp>
       <p:sp>
         <p:nvSpPr>
-          <p:cNvPr id="8" name="页脚占位符 7">
+          <p:cNvPr id="8" name="占位符 7">
             <a:extLst>
               <a:ext uri="{FF2B5EF4-FFF2-40B4-BE49-F238E27FC236}">
                 <a16:creationId xmlns:a16="http://schemas.microsoft.com/office/drawing/2014/main" id="{B3B0F7AA-053C-AA4D-AD80-35331F75E5E1}"/>
@@ -2861,7 +2861,7 @@
           <a:p>
             <a:r>
               <a:rPr kumimoji="1" lang="zh-CN" altLang="en-US"/>
-              <a:t>单击此处编辑母版标题样式</a:t>
+              <a:t>编辑母版标题样式</a:t>
             </a:r>
           </a:p>
         </p:txBody>
@@ -2896,7 +2896,7 @@
       </p:sp>
       <p:sp>
         <p:nvSpPr>
-          <p:cNvPr id="4" name="页脚占位符 3">
+          <p:cNvPr id="4" name="占位符 3">
             <a:extLst>
               <a:ext uri="{FF2B5EF4-FFF2-40B4-BE49-F238E27FC236}">
                 <a16:creationId xmlns:a16="http://schemas.microsoft.com/office/drawing/2014/main" id="{D5265618-A896-5647-87D0-565E9C3C9A57}"/>
@@ -3007,7 +3007,7 @@
       </p:sp>
       <p:sp>
         <p:nvSpPr>
-          <p:cNvPr id="3" name="页脚占位符 2">
+          <p:cNvPr id="3" name="占位符 2">
             <a:extLst>
               <a:ext uri="{FF2B5EF4-FFF2-40B4-BE49-F238E27FC236}">
                 <a16:creationId xmlns:a16="http://schemas.microsoft.com/office/drawing/2014/main" id="{1DA39024-C9AE-734F-8496-D6A531AD30E3}"/>
@@ -3120,7 +3120,7 @@
           <a:p>
             <a:r>
               <a:rPr kumimoji="1" lang="zh-CN" altLang="en-US"/>
-              <a:t>单击此处编辑母版标题样式</a:t>
+              <a:t>编辑母版标题样式</a:t>
             </a:r>
           </a:p>
         </p:txBody>
@@ -3182,7 +3182,7 @@
             <a:pPr lvl="0"/>
             <a:r>
               <a:rPr kumimoji="1" lang="zh-CN" altLang="en-US"/>
-              <a:t>单击此处编辑母版文本样式</a:t>
+              <a:t>编辑母版文本样式</a:t>
             </a:r>
           </a:p>
           <a:p>
@@ -3281,7 +3281,7 @@
             <a:pPr lvl="0"/>
             <a:r>
               <a:rPr kumimoji="1" lang="zh-CN" altLang="en-US"/>
-              <a:t>单击此处编辑母版文本样式</a:t>
+              <a:t>编辑母版文本样式</a:t>
             </a:r>
           </a:p>
         </p:txBody>
@@ -3316,7 +3316,7 @@
       </p:sp>
       <p:sp>
         <p:nvSpPr>
-          <p:cNvPr id="6" name="页脚占位符 5">
+          <p:cNvPr id="6" name="占位符 5">
             <a:extLst>
               <a:ext uri="{FF2B5EF4-FFF2-40B4-BE49-F238E27FC236}">
                 <a16:creationId xmlns:a16="http://schemas.microsoft.com/office/drawing/2014/main" id="{844B726F-C8A7-7540-9FF1-C2016538FA5F}"/>
@@ -3429,7 +3429,7 @@
           <a:p>
             <a:r>
               <a:rPr kumimoji="1" lang="zh-CN" altLang="en-US"/>
-              <a:t>单击此处编辑母版标题样式</a:t>
+              <a:t>编辑母版标题样式</a:t>
             </a:r>
           </a:p>
         </p:txBody>
@@ -3567,7 +3567,7 @@
             <a:pPr lvl="0"/>
             <a:r>
               <a:rPr kumimoji="1" lang="zh-CN" altLang="en-US"/>
-              <a:t>单击此处编辑母版文本样式</a:t>
+              <a:t>编辑母版文本样式</a:t>
             </a:r>
           </a:p>
         </p:txBody>
@@ -3602,7 +3602,7 @@
       </p:sp>
       <p:sp>
         <p:nvSpPr>
-          <p:cNvPr id="6" name="页脚占位符 5">
+          <p:cNvPr id="6" name="占位符 5">
             <a:extLst>
               <a:ext uri="{FF2B5EF4-FFF2-40B4-BE49-F238E27FC236}">
                 <a16:creationId xmlns:a16="http://schemas.microsoft.com/office/drawing/2014/main" id="{6971A4EC-9A7E-5746-A4F8-84CFCAFB1838}"/>
@@ -3721,7 +3721,7 @@
           <a:p>
             <a:r>
               <a:rPr kumimoji="1" lang="zh-CN" altLang="en-US"/>
-              <a:t>单击此处编辑母版标题样式</a:t>
+              <a:t>编辑母版标题样式</a:t>
             </a:r>
           </a:p>
         </p:txBody>
@@ -3760,7 +3760,7 @@
             <a:pPr lvl="0"/>
             <a:r>
               <a:rPr kumimoji="1" lang="zh-CN" altLang="en-US"/>
-              <a:t>单击此处编辑母版文本样式</a:t>
+              <a:t>编辑母版文本样式</a:t>
             </a:r>
           </a:p>
           <a:p>
@@ -3841,7 +3841,7 @@
       </p:sp>
       <p:sp>
         <p:nvSpPr>
-          <p:cNvPr id="5" name="页脚占位符 4">
+          <p:cNvPr id="5" name="占位符 4">
             <a:extLst>
               <a:ext uri="{FF2B5EF4-FFF2-40B4-BE49-F238E27FC236}">
                 <a16:creationId xmlns:a16="http://schemas.microsoft.com/office/drawing/2014/main" id="{F55AADAB-895A-224B-959D-A5C11A166F58}"/>

</xml_diff>